<commit_message>
ppt template dynamic size
</commit_message>
<xml_diff>
--- a/src/main/resources/templates/ppt/keiken.pptx
+++ b/src/main/resources/templates/ppt/keiken.pptx
@@ -126,6 +126,14 @@
 </p:presentation>
 </file>
 
+<file path=ppt/revisionInfo.xml><?xml version="1.0" encoding="utf-8"?>
+<p1510:revInfo xmlns:a="http://schemas.openxmlformats.org/drawingml/2006/main" xmlns:r="http://schemas.openxmlformats.org/officeDocument/2006/relationships" xmlns:p1510="http://schemas.microsoft.com/office/powerpoint/2015/10/main">
+  <p1510:revLst>
+    <p1510:client id="{D993CD2F-F9B4-E15A-0223-7203921AEB31}" v="174" dt="2024-10-31T14:36:29.941"/>
+  </p1510:revLst>
+</p1510:revInfo>
+</file>
+
 <file path=ppt/notesMasters/notesMaster1.xml><?xml version="1.0" encoding="utf-8"?>
 <p:notesMaster xmlns:a="http://schemas.openxmlformats.org/drawingml/2006/main" xmlns:r="http://schemas.openxmlformats.org/officeDocument/2006/relationships" xmlns:p="http://schemas.openxmlformats.org/presentationml/2006/main">
   <p:cSld>
@@ -435,7 +443,7 @@
                 </a:solidFill>
                 <a:latin typeface="Times New Roman"/>
               </a:rPr>
-              <a:t>‹#›</a:t>
+              <a:t>‹N°›</a:t>
             </a:fld>
             <a:endParaRPr lang="en-US" sz="1400" b="0" strike="noStrike" spc="-1">
               <a:solidFill>
@@ -841,7 +849,7 @@
           <a:lstStyle/>
           <a:p>
             <a:fld id="{2DF62B69-2A2D-41E9-A5F8-5CBE7519E28E}" type="slidenum">
-              <a:t>‹#›</a:t>
+              <a:t>‹N°›</a:t>
             </a:fld>
             <a:endParaRPr/>
           </a:p>
@@ -928,7 +936,7 @@
           <a:lstStyle/>
           <a:p>
             <a:fld id="{E9B1214D-5239-4DFC-B82C-AC2E57EB7BF7}" type="slidenum">
-              <a:t>‹#›</a:t>
+              <a:t>‹N°›</a:t>
             </a:fld>
             <a:endParaRPr/>
           </a:p>
@@ -1015,7 +1023,7 @@
           <a:lstStyle/>
           <a:p>
             <a:fld id="{626D9DC1-D078-4C5C-BF73-B2DC38448E67}" type="slidenum">
-              <a:t>‹#›</a:t>
+              <a:t>‹N°›</a:t>
             </a:fld>
             <a:endParaRPr/>
           </a:p>
@@ -1102,7 +1110,7 @@
           <a:lstStyle/>
           <a:p>
             <a:fld id="{F2D2C08E-A5D8-4CB1-A874-2A79DE7334A8}" type="slidenum">
-              <a:t>‹#›</a:t>
+              <a:t>‹N°›</a:t>
             </a:fld>
             <a:endParaRPr/>
           </a:p>
@@ -1189,7 +1197,7 @@
           <a:lstStyle/>
           <a:p>
             <a:fld id="{BE6ADC8A-C6EA-44FB-8C11-DF68788C5EB6}" type="slidenum">
-              <a:t>‹#›</a:t>
+              <a:t>‹N°›</a:t>
             </a:fld>
             <a:endParaRPr/>
           </a:p>
@@ -1276,7 +1284,7 @@
           <a:lstStyle/>
           <a:p>
             <a:fld id="{0BA27ED3-6686-4C08-BC47-178B2549EE97}" type="slidenum">
-              <a:t>‹#›</a:t>
+              <a:t>‹N°›</a:t>
             </a:fld>
             <a:endParaRPr/>
           </a:p>
@@ -1558,7 +1566,7 @@
           <a:lstStyle/>
           <a:p>
             <a:fld id="{BE4FA86D-8DF4-4456-BD93-C1D8EFA39B2E}" type="slidenum">
-              <a:t>‹#›</a:t>
+              <a:t>‹N°›</a:t>
             </a:fld>
             <a:endParaRPr/>
           </a:p>
@@ -1645,7 +1653,7 @@
           <a:lstStyle/>
           <a:p>
             <a:fld id="{20FE843B-53DD-403D-9F3C-5583162DD2BF}" type="slidenum">
-              <a:t>‹#›</a:t>
+              <a:t>‹N°›</a:t>
             </a:fld>
             <a:endParaRPr/>
           </a:p>
@@ -1861,7 +1869,7 @@
           <a:lstStyle/>
           <a:p>
             <a:fld id="{8FDEEA62-33C0-4798-94A3-01CA44372E86}" type="slidenum">
-              <a:t>‹#›</a:t>
+              <a:t>‹N°›</a:t>
             </a:fld>
             <a:endParaRPr/>
           </a:p>
@@ -1948,7 +1956,7 @@
           <a:lstStyle/>
           <a:p>
             <a:fld id="{3134CDD4-AA7F-40AC-B651-9BBDDD2BBEDD}" type="slidenum">
-              <a:t>‹#›</a:t>
+              <a:t>‹N°›</a:t>
             </a:fld>
             <a:endParaRPr/>
           </a:p>
@@ -2076,7 +2084,7 @@
           <a:lstStyle/>
           <a:p>
             <a:fld id="{D2C17111-2DC3-4370-A1E9-6AAA5C3D4E8B}" type="slidenum">
-              <a:t>‹#›</a:t>
+              <a:t>‹N°›</a:t>
             </a:fld>
             <a:endParaRPr/>
           </a:p>
@@ -2309,7 +2317,7 @@
                 </a:solidFill>
                 <a:latin typeface="Calibri"/>
               </a:rPr>
-              <a:t>‹#›</a:t>
+              <a:t>‹N°›</a:t>
             </a:fld>
             <a:endParaRPr lang="en-US" sz="1200" b="0" strike="noStrike" spc="-1">
               <a:solidFill>
@@ -2819,7 +2827,7 @@
                 </a:solidFill>
                 <a:latin typeface="Calibri"/>
               </a:rPr>
-              <a:t>‹#›</a:t>
+              <a:t>‹N°›</a:t>
             </a:fld>
             <a:endParaRPr lang="en-US" sz="1200" b="0" strike="noStrike" spc="-1">
               <a:solidFill>
@@ -3329,7 +3337,7 @@
                 </a:solidFill>
                 <a:latin typeface="Calibri"/>
               </a:rPr>
-              <a:t>‹#›</a:t>
+              <a:t>‹N°›</a:t>
             </a:fld>
             <a:endParaRPr lang="en-US" sz="1200" b="0" strike="noStrike" spc="-1">
               <a:solidFill>
@@ -3839,7 +3847,7 @@
                 </a:solidFill>
                 <a:latin typeface="Calibri"/>
               </a:rPr>
-              <a:t>‹#›</a:t>
+              <a:t>‹N°›</a:t>
             </a:fld>
             <a:endParaRPr lang="en-US" sz="1200" b="0" strike="noStrike" spc="-1">
               <a:solidFill>
@@ -4349,7 +4357,7 @@
                 </a:solidFill>
                 <a:latin typeface="Calibri"/>
               </a:rPr>
-              <a:t>‹#›</a:t>
+              <a:t>‹N°›</a:t>
             </a:fld>
             <a:endParaRPr lang="en-US" sz="1200" b="0" strike="noStrike" spc="-1">
               <a:solidFill>
@@ -4859,7 +4867,7 @@
                 </a:solidFill>
                 <a:latin typeface="Calibri"/>
               </a:rPr>
-              <a:t>‹#›</a:t>
+              <a:t>‹N°›</a:t>
             </a:fld>
             <a:endParaRPr lang="en-US" sz="1200" b="0" strike="noStrike" spc="-1">
               <a:solidFill>
@@ -6139,7 +6147,7 @@
                 </a:solidFill>
                 <a:latin typeface="Calibri"/>
               </a:rPr>
-              <a:t>‹#›</a:t>
+              <a:t>‹N°›</a:t>
             </a:fld>
             <a:endParaRPr lang="en-US" sz="1200" b="0" strike="noStrike" spc="-1">
               <a:solidFill>
@@ -6649,7 +6657,7 @@
                 </a:solidFill>
                 <a:latin typeface="Calibri"/>
               </a:rPr>
-              <a:t>‹#›</a:t>
+              <a:t>‹N°›</a:t>
             </a:fld>
             <a:endParaRPr lang="en-US" sz="1200" b="0" strike="noStrike" spc="-1">
               <a:solidFill>
@@ -7571,7 +7579,7 @@
                 </a:solidFill>
                 <a:latin typeface="Calibri"/>
               </a:rPr>
-              <a:t>‹#›</a:t>
+              <a:t>‹N°›</a:t>
             </a:fld>
             <a:endParaRPr lang="en-US" sz="1200" b="0" strike="noStrike" spc="-1">
               <a:solidFill>
@@ -8081,7 +8089,7 @@
                 </a:solidFill>
                 <a:latin typeface="Calibri"/>
               </a:rPr>
-              <a:t>‹#›</a:t>
+              <a:t>‹N°›</a:t>
             </a:fld>
             <a:endParaRPr lang="en-US" sz="1200" b="0" strike="noStrike" spc="-1">
               <a:solidFill>
@@ -8635,7 +8643,7 @@
                 </a:solidFill>
                 <a:latin typeface="Calibri"/>
               </a:rPr>
-              <a:t>‹#›</a:t>
+              <a:t>‹N°›</a:t>
             </a:fld>
             <a:endParaRPr lang="en-US" sz="1200" b="0" strike="noStrike" spc="-1">
               <a:solidFill>
@@ -9588,7 +9596,7 @@
           <p:nvPr>
             <p:extLst>
               <p:ext uri="{D42A27DB-BD31-4B8C-83A1-F6EECF244321}">
-                <p14:modId xmlns:p14="http://schemas.microsoft.com/office/powerpoint/2010/main" val="1042793980"/>
+                <p14:modId xmlns:p14="http://schemas.microsoft.com/office/powerpoint/2010/main" val="3698376876"/>
               </p:ext>
             </p:extLst>
           </p:nvPr>
@@ -9716,7 +9724,7 @@
                       </a:endParaRPr>
                     </a:p>
                     <a:p>
-                      <a:pPr marL="216000" indent="-216000" algn="l" defTabSz="914400">
+                      <a:pPr marL="215900" indent="-215900" algn="l" defTabSz="914400">
                         <a:lnSpc>
                           <a:spcPct val="100000"/>
                         </a:lnSpc>
@@ -9735,9 +9743,197 @@
                             <a:srgbClr val="2D2F34"/>
                           </a:solidFill>
                           <a:latin typeface="Calibri Light"/>
+                        </a:rPr>
+                        <a:t>factDescription,15</a:t>
+                      </a:r>
+                      <a:endParaRPr lang="en-US" sz="1100" b="0" strike="noStrike" spc="-1" dirty="0" err="1">
+                        <a:solidFill>
+                          <a:srgbClr val="000000"/>
+                        </a:solidFill>
+                        <a:latin typeface="Arial"/>
+                      </a:endParaRPr>
+                    </a:p>
+                    <a:p>
+                      <a:pPr algn="l" defTabSz="914400">
+                        <a:lnSpc>
+                          <a:spcPct val="100000"/>
+                        </a:lnSpc>
+                        <a:tabLst>
+                          <a:tab pos="0" algn="l"/>
+                        </a:tabLst>
+                      </a:pPr>
+                      <a:r>
+                        <a:rPr lang="fr-FR" sz="1200" b="1" strike="noStrike" spc="-1" dirty="0">
+                          <a:solidFill>
+                            <a:srgbClr val="2D2F34"/>
+                          </a:solidFill>
+                          <a:latin typeface="Calibri Light"/>
                           <a:ea typeface="Times New Roman"/>
                         </a:rPr>
-                        <a:t>factDescription</a:t>
+                        <a:t>Technologies : </a:t>
+                      </a:r>
+                      <a:r>
+                        <a:rPr lang="en-US" sz="1100" b="0" strike="noStrike" spc="-1" dirty="0">
+                          <a:solidFill>
+                            <a:srgbClr val="2D2F34"/>
+                          </a:solidFill>
+                          <a:latin typeface="Calibri Light"/>
+                          <a:ea typeface="Times New Roman"/>
+                        </a:rPr>
+                        <a:t> </a:t>
+                      </a:r>
+                      <a:r>
+                        <a:rPr lang="fr-FR" sz="1100" b="0" strike="noStrike" spc="-1" dirty="0">
+                          <a:solidFill>
+                            <a:srgbClr val="2D2F34"/>
+                          </a:solidFill>
+                          <a:latin typeface="Calibri Light"/>
+                          <a:ea typeface="Times New Roman"/>
+                        </a:rPr>
+                        <a:t>linkedSkills.</a:t>
+                      </a:r>
+                      <a:endParaRPr lang="en-US" sz="1100" b="0" strike="noStrike" spc="-1" dirty="0">
+                        <a:solidFill>
+                          <a:srgbClr val="000000"/>
+                        </a:solidFill>
+                        <a:latin typeface="Arial"/>
+                      </a:endParaRPr>
+                    </a:p>
+                  </a:txBody>
+                  <a:tcPr>
+                    <a:lnL w="12700" cap="flat" cmpd="sng" algn="ctr">
+                      <a:noFill/>
+                      <a:prstDash val="solid"/>
+                      <a:round/>
+                      <a:headEnd type="none" w="med" len="med"/>
+                      <a:tailEnd type="none" w="med" len="med"/>
+                    </a:lnL>
+                    <a:lnR w="12700" cap="flat" cmpd="sng" algn="ctr">
+                      <a:noFill/>
+                      <a:prstDash val="solid"/>
+                      <a:round/>
+                      <a:headEnd type="none" w="med" len="med"/>
+                      <a:tailEnd type="none" w="med" len="med"/>
+                    </a:lnR>
+                    <a:lnT w="12700" cap="flat" cmpd="sng" algn="ctr">
+                      <a:noFill/>
+                      <a:prstDash val="solid"/>
+                      <a:round/>
+                      <a:headEnd type="none" w="med" len="med"/>
+                      <a:tailEnd type="none" w="med" len="med"/>
+                    </a:lnT>
+                    <a:lnB w="12700" cap="flat" cmpd="sng" algn="ctr">
+                      <a:noFill/>
+                      <a:prstDash val="solid"/>
+                      <a:round/>
+                      <a:headEnd type="none" w="med" len="med"/>
+                      <a:tailEnd type="none" w="med" len="med"/>
+                    </a:lnB>
+                    <a:lnTlToBr w="12700" cmpd="sng">
+                      <a:noFill/>
+                      <a:prstDash val="solid"/>
+                    </a:lnTlToBr>
+                    <a:lnBlToTr w="12700" cmpd="sng">
+                      <a:noFill/>
+                      <a:prstDash val="solid"/>
+                    </a:lnBlToTr>
+                    <a:noFill/>
+                  </a:tcPr>
+                </a:tc>
+                <a:tc>
+                  <a:txBody>
+                    <a:bodyPr/>
+                    <a:lstStyle/>
+                    <a:p>
+                      <a:pPr algn="l" defTabSz="914400">
+                        <a:lnSpc>
+                          <a:spcPct val="100000"/>
+                        </a:lnSpc>
+                        <a:tabLst>
+                          <a:tab pos="0" algn="l"/>
+                        </a:tabLst>
+                      </a:pPr>
+                      <a:r>
+                        <a:rPr lang="en-US" sz="1600" b="1" i="0" strike="noStrike" spc="-1" dirty="0">
+                          <a:solidFill>
+                            <a:srgbClr val="4D708C"/>
+                          </a:solidFill>
+                          <a:latin typeface="+mn-lt"/>
+                          <a:ea typeface="Times New Roman"/>
+                        </a:rPr>
+                        <a:t>startDate – endDate</a:t>
+                      </a:r>
+                      <a:r>
+                        <a:rPr lang="en-US" sz="1600" b="1" i="0" strike="noStrike" spc="-1" dirty="0">
+                          <a:solidFill>
+                            <a:srgbClr val="2D2F34"/>
+                          </a:solidFill>
+                          <a:latin typeface="+mn-lt"/>
+                          <a:ea typeface="Times New Roman"/>
+                        </a:rPr>
+                        <a:t> | </a:t>
+                      </a:r>
+                      <a:r>
+                        <a:rPr lang="fr-FR" sz="1600" b="1" kern="1200" dirty="0">
+                          <a:solidFill>
+                            <a:schemeClr val="tx1"/>
+                          </a:solidFill>
+                          <a:effectLst/>
+                          <a:latin typeface="+mn-lt"/>
+                          <a:ea typeface="+mn-ea"/>
+                          <a:cs typeface="+mn-cs"/>
+                        </a:rPr>
+                        <a:t>factTitle</a:t>
+                      </a:r>
+                      <a:endParaRPr lang="en-US" sz="1600" b="1" i="0" strike="noStrike" spc="-1" dirty="0">
+                        <a:solidFill>
+                          <a:schemeClr val="tx1"/>
+                        </a:solidFill>
+                        <a:latin typeface="+mn-lt"/>
+                        <a:ea typeface="Times New Roman"/>
+                      </a:endParaRPr>
+                    </a:p>
+                    <a:p>
+                      <a:pPr algn="l"/>
+                      <a:r>
+                        <a:rPr lang="en-US" sz="1400" b="0" i="1" strike="noStrike" spc="-1" dirty="0">
+                          <a:solidFill>
+                            <a:srgbClr val="2D2F34"/>
+                          </a:solidFill>
+                          <a:latin typeface="+mn-lt"/>
+                          <a:ea typeface="Times New Roman"/>
+                        </a:rPr>
+                        <a:t>location –  city .</a:t>
+                      </a:r>
+                      <a:endParaRPr lang="en-US" sz="1400" b="0" strike="noStrike" spc="-1" dirty="0">
+                        <a:solidFill>
+                          <a:srgbClr val="000000"/>
+                        </a:solidFill>
+                        <a:latin typeface="Arial"/>
+                      </a:endParaRPr>
+                    </a:p>
+                    <a:p>
+                      <a:pPr marL="215900" indent="-215900" algn="l" defTabSz="914400">
+                        <a:lnSpc>
+                          <a:spcPct val="100000"/>
+                        </a:lnSpc>
+                        <a:buClr>
+                          <a:srgbClr val="4D708C"/>
+                        </a:buClr>
+                        <a:buFont typeface="Symbol" charset="2"/>
+                        <a:buChar char=""/>
+                        <a:tabLst>
+                          <a:tab pos="0" algn="l"/>
+                        </a:tabLst>
+                      </a:pPr>
+                      <a:r>
+                        <a:rPr lang="en-US" sz="1100" b="0" i="0" u="none" strike="noStrike" spc="-1" noProof="0" dirty="0">
+                          <a:solidFill>
+                            <a:srgbClr val="2D2F34"/>
+                          </a:solidFill>
+                          <a:latin typeface="Calibri Light"/>
+                        </a:rPr>
+                        <a:t>factDescription,15</a:t>
                       </a:r>
                       <a:endParaRPr lang="en-US" sz="1100" b="0" strike="noStrike" spc="-1" dirty="0">
                         <a:solidFill>
@@ -9906,7 +10102,7 @@
                       </a:endParaRPr>
                     </a:p>
                     <a:p>
-                      <a:pPr marL="216000" indent="-216000" algn="l" defTabSz="914400">
+                      <a:pPr marL="215900" indent="-215900" algn="l" defTabSz="914400">
                         <a:lnSpc>
                           <a:spcPct val="100000"/>
                         </a:lnSpc>
@@ -9920,204 +10116,13 @@
                         </a:tabLst>
                       </a:pPr>
                       <a:r>
-                        <a:rPr lang="en-US" sz="1100" b="0" strike="noStrike" spc="-1" dirty="0">
+                        <a:rPr lang="en-US" sz="1100" b="0" i="0" u="none" strike="noStrike" spc="-1" noProof="0" dirty="0">
                           <a:solidFill>
                             <a:srgbClr val="2D2F34"/>
                           </a:solidFill>
                           <a:latin typeface="Calibri Light"/>
-                          <a:ea typeface="Times New Roman"/>
                         </a:rPr>
-                        <a:t>factDescription</a:t>
-                      </a:r>
-                      <a:endParaRPr lang="en-US" sz="1100" b="0" strike="noStrike" spc="-1" dirty="0">
-                        <a:solidFill>
-                          <a:srgbClr val="000000"/>
-                        </a:solidFill>
-                        <a:latin typeface="Arial"/>
-                      </a:endParaRPr>
-                    </a:p>
-                    <a:p>
-                      <a:pPr algn="l" defTabSz="914400">
-                        <a:lnSpc>
-                          <a:spcPct val="100000"/>
-                        </a:lnSpc>
-                        <a:tabLst>
-                          <a:tab pos="0" algn="l"/>
-                        </a:tabLst>
-                      </a:pPr>
-                      <a:r>
-                        <a:rPr lang="fr-FR" sz="1200" b="1" strike="noStrike" spc="-1" dirty="0">
-                          <a:solidFill>
-                            <a:srgbClr val="2D2F34"/>
-                          </a:solidFill>
-                          <a:latin typeface="Calibri Light"/>
-                          <a:ea typeface="Times New Roman"/>
-                        </a:rPr>
-                        <a:t>Technologies : </a:t>
-                      </a:r>
-                      <a:r>
-                        <a:rPr lang="en-US" sz="1100" b="0" strike="noStrike" spc="-1" dirty="0">
-                          <a:solidFill>
-                            <a:srgbClr val="2D2F34"/>
-                          </a:solidFill>
-                          <a:latin typeface="Calibri Light"/>
-                          <a:ea typeface="Times New Roman"/>
-                        </a:rPr>
-                        <a:t> </a:t>
-                      </a:r>
-                      <a:r>
-                        <a:rPr lang="fr-FR" sz="1100" b="0" strike="noStrike" spc="-1" dirty="0">
-                          <a:solidFill>
-                            <a:srgbClr val="2D2F34"/>
-                          </a:solidFill>
-                          <a:latin typeface="Calibri Light"/>
-                          <a:ea typeface="Times New Roman"/>
-                        </a:rPr>
-                        <a:t>linkedSkills.</a:t>
-                      </a:r>
-                      <a:endParaRPr lang="en-US" sz="1100" b="0" strike="noStrike" spc="-1" dirty="0">
-                        <a:solidFill>
-                          <a:srgbClr val="000000"/>
-                        </a:solidFill>
-                        <a:latin typeface="Arial"/>
-                      </a:endParaRPr>
-                    </a:p>
-                  </a:txBody>
-                  <a:tcPr>
-                    <a:lnL w="12700" cap="flat" cmpd="sng" algn="ctr">
-                      <a:noFill/>
-                      <a:prstDash val="solid"/>
-                      <a:round/>
-                      <a:headEnd type="none" w="med" len="med"/>
-                      <a:tailEnd type="none" w="med" len="med"/>
-                    </a:lnL>
-                    <a:lnR w="12700" cap="flat" cmpd="sng" algn="ctr">
-                      <a:noFill/>
-                      <a:prstDash val="solid"/>
-                      <a:round/>
-                      <a:headEnd type="none" w="med" len="med"/>
-                      <a:tailEnd type="none" w="med" len="med"/>
-                    </a:lnR>
-                    <a:lnT w="12700" cap="flat" cmpd="sng" algn="ctr">
-                      <a:noFill/>
-                      <a:prstDash val="solid"/>
-                      <a:round/>
-                      <a:headEnd type="none" w="med" len="med"/>
-                      <a:tailEnd type="none" w="med" len="med"/>
-                    </a:lnT>
-                    <a:lnB w="12700" cap="flat" cmpd="sng" algn="ctr">
-                      <a:noFill/>
-                      <a:prstDash val="solid"/>
-                      <a:round/>
-                      <a:headEnd type="none" w="med" len="med"/>
-                      <a:tailEnd type="none" w="med" len="med"/>
-                    </a:lnB>
-                    <a:lnTlToBr w="12700" cmpd="sng">
-                      <a:noFill/>
-                      <a:prstDash val="solid"/>
-                    </a:lnTlToBr>
-                    <a:lnBlToTr w="12700" cmpd="sng">
-                      <a:noFill/>
-                      <a:prstDash val="solid"/>
-                    </a:lnBlToTr>
-                    <a:noFill/>
-                  </a:tcPr>
-                </a:tc>
-                <a:tc>
-                  <a:txBody>
-                    <a:bodyPr/>
-                    <a:lstStyle/>
-                    <a:p>
-                      <a:pPr algn="l" defTabSz="914400">
-                        <a:lnSpc>
-                          <a:spcPct val="100000"/>
-                        </a:lnSpc>
-                        <a:tabLst>
-                          <a:tab pos="0" algn="l"/>
-                        </a:tabLst>
-                      </a:pPr>
-                      <a:r>
-                        <a:rPr lang="en-US" sz="1600" b="1" i="0" strike="noStrike" spc="-1" dirty="0">
-                          <a:solidFill>
-                            <a:srgbClr val="4D708C"/>
-                          </a:solidFill>
-                          <a:latin typeface="+mn-lt"/>
-                          <a:ea typeface="Times New Roman"/>
-                        </a:rPr>
-                        <a:t>startDate – endDate</a:t>
-                      </a:r>
-                      <a:r>
-                        <a:rPr lang="en-US" sz="1600" b="1" i="0" strike="noStrike" spc="-1" dirty="0">
-                          <a:solidFill>
-                            <a:srgbClr val="2D2F34"/>
-                          </a:solidFill>
-                          <a:latin typeface="+mn-lt"/>
-                          <a:ea typeface="Times New Roman"/>
-                        </a:rPr>
-                        <a:t> | </a:t>
-                      </a:r>
-                      <a:r>
-                        <a:rPr lang="fr-FR" sz="1600" b="1" kern="1200" dirty="0">
-                          <a:solidFill>
-                            <a:schemeClr val="tx1"/>
-                          </a:solidFill>
-                          <a:effectLst/>
-                          <a:latin typeface="+mn-lt"/>
-                          <a:ea typeface="+mn-ea"/>
-                          <a:cs typeface="+mn-cs"/>
-                        </a:rPr>
-                        <a:t>factTitle</a:t>
-                      </a:r>
-                      <a:endParaRPr lang="en-US" sz="1600" b="1" i="0" strike="noStrike" spc="-1" dirty="0">
-                        <a:solidFill>
-                          <a:schemeClr val="tx1"/>
-                        </a:solidFill>
-                        <a:latin typeface="+mn-lt"/>
-                        <a:ea typeface="Times New Roman"/>
-                      </a:endParaRPr>
-                    </a:p>
-                    <a:p>
-                      <a:pPr algn="l"/>
-                      <a:r>
-                        <a:rPr lang="en-US" sz="1400" b="0" i="1" strike="noStrike" spc="-1" dirty="0">
-                          <a:solidFill>
-                            <a:srgbClr val="2D2F34"/>
-                          </a:solidFill>
-                          <a:latin typeface="+mn-lt"/>
-                          <a:ea typeface="Times New Roman"/>
-                        </a:rPr>
-                        <a:t>location –  city .</a:t>
-                      </a:r>
-                      <a:endParaRPr lang="en-US" sz="1400" b="0" strike="noStrike" spc="-1" dirty="0">
-                        <a:solidFill>
-                          <a:srgbClr val="000000"/>
-                        </a:solidFill>
-                        <a:latin typeface="Arial"/>
-                      </a:endParaRPr>
-                    </a:p>
-                    <a:p>
-                      <a:pPr marL="216000" indent="-216000" algn="l" defTabSz="914400">
-                        <a:lnSpc>
-                          <a:spcPct val="100000"/>
-                        </a:lnSpc>
-                        <a:buClr>
-                          <a:srgbClr val="4D708C"/>
-                        </a:buClr>
-                        <a:buFont typeface="Symbol" charset="2"/>
-                        <a:buChar char=""/>
-                        <a:tabLst>
-                          <a:tab pos="0" algn="l"/>
-                        </a:tabLst>
-                      </a:pPr>
-                      <a:r>
-                        <a:rPr lang="en-US" sz="1100" b="0" strike="noStrike" spc="-1" dirty="0">
-                          <a:solidFill>
-                            <a:srgbClr val="2D2F34"/>
-                          </a:solidFill>
-                          <a:latin typeface="Calibri Light"/>
-                          <a:ea typeface="Times New Roman"/>
-                        </a:rPr>
-                        <a:t>factDescription</a:t>
+                        <a:t>factDescription,15</a:t>
                       </a:r>
                       <a:endParaRPr lang="en-US" sz="1100" b="0" strike="noStrike" spc="-1" dirty="0">
                         <a:solidFill>
@@ -10303,7 +10308,7 @@
                       </a:endParaRPr>
                     </a:p>
                     <a:p>
-                      <a:pPr marL="216000" indent="-216000" algn="l" defTabSz="914400">
+                      <a:pPr marL="215900" lvl="0" indent="-215900" algn="l" defTabSz="914400">
                         <a:lnSpc>
                           <a:spcPct val="100000"/>
                         </a:lnSpc>
@@ -10317,14 +10322,13 @@
                         </a:tabLst>
                       </a:pPr>
                       <a:r>
-                        <a:rPr lang="en-US" sz="1100" b="0" strike="noStrike" spc="-1" dirty="0">
+                        <a:rPr lang="en-US" sz="1100" b="0" i="0" u="none" strike="noStrike" spc="-1" noProof="0" dirty="0">
                           <a:solidFill>
                             <a:srgbClr val="2D2F34"/>
                           </a:solidFill>
                           <a:latin typeface="Calibri Light"/>
-                          <a:ea typeface="Times New Roman"/>
                         </a:rPr>
-                        <a:t>factDescription</a:t>
+                        <a:t>factDescription,15</a:t>
                       </a:r>
                       <a:endParaRPr lang="en-US" sz="1100" b="0" strike="noStrike" spc="-1" dirty="0">
                         <a:solidFill>
@@ -10493,7 +10497,7 @@
                       </a:endParaRPr>
                     </a:p>
                     <a:p>
-                      <a:pPr marL="216000" indent="-216000" algn="l" defTabSz="914400">
+                      <a:pPr marL="215900" lvl="0" indent="-215900" algn="l" defTabSz="914400">
                         <a:lnSpc>
                           <a:spcPct val="100000"/>
                         </a:lnSpc>
@@ -10507,14 +10511,13 @@
                         </a:tabLst>
                       </a:pPr>
                       <a:r>
-                        <a:rPr lang="en-US" sz="1100" b="0" strike="noStrike" spc="-1" dirty="0">
+                        <a:rPr lang="en-US" sz="1100" b="0" i="0" u="none" strike="noStrike" spc="-1" noProof="0" dirty="0">
                           <a:solidFill>
                             <a:srgbClr val="2D2F34"/>
                           </a:solidFill>
                           <a:latin typeface="Calibri Light"/>
-                          <a:ea typeface="Times New Roman"/>
                         </a:rPr>
-                        <a:t>factDescription</a:t>
+                        <a:t>factDescription,15</a:t>
                       </a:r>
                       <a:endParaRPr lang="en-US" sz="1100" b="0" strike="noStrike" spc="-1" dirty="0">
                         <a:solidFill>
@@ -10683,7 +10686,7 @@
                       </a:endParaRPr>
                     </a:p>
                     <a:p>
-                      <a:pPr marL="216000" indent="-216000" algn="l" defTabSz="914400">
+                      <a:pPr marL="215900" indent="-215900" algn="l" defTabSz="914400">
                         <a:lnSpc>
                           <a:spcPct val="100000"/>
                         </a:lnSpc>
@@ -10704,7 +10707,7 @@
                           <a:latin typeface="Calibri Light"/>
                           <a:ea typeface="Times New Roman"/>
                         </a:rPr>
-                        <a:t>factDescription</a:t>
+                        <a:t>factDescription,15</a:t>
                       </a:r>
                       <a:endParaRPr lang="en-US" sz="1100" b="0" strike="noStrike" spc="-1" dirty="0">
                         <a:solidFill>
@@ -10914,43 +10917,36 @@
         </p:nvSpPr>
         <p:spPr>
           <a:xfrm>
-            <a:off x="209290" y="1079520"/>
-            <a:ext cx="3565696" cy="754053"/>
+            <a:off x="295554" y="1212111"/>
+            <a:ext cx="3436300" cy="477054"/>
           </a:xfrm>
           <a:prstGeom prst="rect">
             <a:avLst/>
           </a:prstGeom>
         </p:spPr>
         <p:txBody>
-          <a:bodyPr vert="horz" wrap="square" lIns="0" tIns="0" rIns="0" bIns="0" rtlCol="0">
+          <a:bodyPr vert="horz" wrap="square" lIns="0" tIns="0" rIns="0" bIns="0" rtlCol="0" anchor="t">
             <a:spAutoFit/>
           </a:bodyPr>
           <a:lstStyle/>
           <a:p>
-            <a:pPr marL="22223" marR="5079" algn="r"/>
-            <a:endParaRPr lang="fr-FR" b="1" dirty="0">
-              <a:solidFill>
-                <a:srgbClr val="4D708C"/>
-              </a:solidFill>
-              <a:ea typeface="Times" charset="0"/>
-              <a:cs typeface="Times" charset="0"/>
-            </a:endParaRPr>
-          </a:p>
-          <a:p>
-            <a:pPr marL="22223" marR="5079" algn="r"/>
+            <a:pPr marL="21590" marR="4445" algn="r"/>
             <a:r>
               <a:rPr lang="fr-FR" b="1" dirty="0">
                 <a:solidFill>
                   <a:srgbClr val="4D708C"/>
                 </a:solidFill>
                 <a:ea typeface="Times" charset="0"/>
-                <a:cs typeface="Times" charset="0"/>
+                <a:cs typeface="Times"/>
               </a:rPr>
               <a:t>city</a:t>
             </a:r>
-          </a:p>
-          <a:p>
-            <a:pPr marL="22223" marR="5079" algn="r"/>
+            <a:endParaRPr lang="fr-FR" dirty="0">
+              <a:cs typeface="Times"/>
+            </a:endParaRPr>
+          </a:p>
+          <a:p>
+            <a:pPr marL="21590" marR="4445" algn="r"/>
             <a:r>
               <a:rPr lang="en-US" sz="1300" dirty="0">
                 <a:solidFill>
@@ -10958,13 +10954,14 @@
                 </a:solidFill>
                 <a:latin typeface="+mj-lt"/>
               </a:rPr>
-              <a:t>abstractProfile</a:t>
+              <a:t>abstractProfile,20</a:t>
             </a:r>
-            <a:endParaRPr lang="fr-FR" sz="1300" dirty="0">
+            <a:endParaRPr lang="fr-FR" sz="1300" dirty="0" err="1">
               <a:solidFill>
                 <a:srgbClr val="4D708C"/>
               </a:solidFill>
               <a:latin typeface="+mj-lt"/>
+              <a:cs typeface="Calibri Light" panose="020F0302020204030204"/>
             </a:endParaRPr>
           </a:p>
         </p:txBody>
@@ -11421,7 +11418,7 @@
         </p:nvSpPr>
         <p:spPr>
           <a:xfrm>
-            <a:off x="1013388" y="893054"/>
+            <a:off x="999011" y="734903"/>
             <a:ext cx="2865151" cy="430887"/>
           </a:xfrm>
           <a:prstGeom prst="rect">

</xml_diff>